<commit_message>
docs: remove TCC references and frame project as general ICT research
</commit_message>
<xml_diff>
--- a/docs/apresentacao_rerankers.pptx
+++ b/docs/apresentacao_rerankers.pptx
@@ -3207,7 +3207,7 @@
               </a:defRPr>
             </a:pPr>
             <a:r>
-              <a:t>AVALIAÇÃO DE RE-RANKING NEURAL (TWO-STAGE RAG) — TCC</a:t>
+              <a:t>AVALIAÇÃO DE RE-RANKING NEURAL (TWO-STAGE RAG) — PESQUISA ICT</a:t>
             </a:r>
           </a:p>
         </p:txBody>
@@ -3387,7 +3387,7 @@
               </a:defRPr>
             </a:pPr>
             <a:r>
-              <a:t>AVALIAÇÃO DE RE-RANKING NEURAL (TWO-STAGE RAG) — TCC</a:t>
+              <a:t>AVALIAÇÃO DE RE-RANKING NEURAL (TWO-STAGE RAG) — PESQUISA ICT</a:t>
             </a:r>
           </a:p>
         </p:txBody>
@@ -3590,7 +3590,7 @@
               </a:defRPr>
             </a:pPr>
             <a:r>
-              <a:t>AVALIAÇÃO DE RE-RANKING NEURAL (TWO-STAGE RAG) — TCC</a:t>
+              <a:t>AVALIAÇÃO DE RE-RANKING NEURAL (TWO-STAGE RAG) — PESQUISA ICT</a:t>
             </a:r>
           </a:p>
         </p:txBody>
@@ -3794,7 +3794,7 @@
               </a:defRPr>
             </a:pPr>
             <a:r>
-              <a:t>AVALIAÇÃO DE RE-RANKING NEURAL (TWO-STAGE RAG) — TCC</a:t>
+              <a:t>AVALIAÇÃO DE RE-RANKING NEURAL (TWO-STAGE RAG) — PESQUISA ICT</a:t>
             </a:r>
           </a:p>
         </p:txBody>
@@ -3975,7 +3975,7 @@
               </a:defRPr>
             </a:pPr>
             <a:r>
-              <a:t>AVALIAÇÃO DE RE-RANKING NEURAL (TWO-STAGE RAG) — TCC</a:t>
+              <a:t>AVALIAÇÃO DE RE-RANKING NEURAL (TWO-STAGE RAG) — PESQUISA ICT</a:t>
             </a:r>
           </a:p>
         </p:txBody>
@@ -4179,7 +4179,7 @@
               </a:defRPr>
             </a:pPr>
             <a:r>
-              <a:t>AVALIAÇÃO DE RE-RANKING NEURAL (TWO-STAGE RAG) — TCC</a:t>
+              <a:t>AVALIAÇÃO DE RE-RANKING NEURAL (TWO-STAGE RAG) — PESQUISA ICT</a:t>
             </a:r>
           </a:p>
         </p:txBody>

</xml_diff>